<commit_message>
Event handler eg 1
</commit_message>
<xml_diff>
--- a/Day/PPTs/ReactJS_Fundamentals.pptx
+++ b/Day/PPTs/ReactJS_Fundamentals.pptx
@@ -400,7 +400,7 @@
           <a:p>
             <a:fld id="{5BCAD085-E8A6-8845-BD4E-CB4CCA059FC4}" type="datetimeFigureOut">
               <a:rPr lang="en-US" smtClean="0"/>
-              <a:t>8/18/2026</a:t>
+              <a:t>8/20/2026</a:t>
             </a:fld>
             <a:endParaRPr lang="en-US"/>
           </a:p>
@@ -613,7 +613,7 @@
           <a:p>
             <a:fld id="{5BCAD085-E8A6-8845-BD4E-CB4CCA059FC4}" type="datetimeFigureOut">
               <a:rPr lang="en-US" smtClean="0"/>
-              <a:t>8/18/2026</a:t>
+              <a:t>8/20/2026</a:t>
             </a:fld>
             <a:endParaRPr lang="en-US"/>
           </a:p>
@@ -936,7 +936,7 @@
           <a:p>
             <a:fld id="{5BCAD085-E8A6-8845-BD4E-CB4CCA059FC4}" type="datetimeFigureOut">
               <a:rPr lang="en-US" smtClean="0"/>
-              <a:t>8/18/2026</a:t>
+              <a:t>8/20/2026</a:t>
             </a:fld>
             <a:endParaRPr lang="en-US"/>
           </a:p>
@@ -1215,7 +1215,7 @@
           <a:p>
             <a:fld id="{5BCAD085-E8A6-8845-BD4E-CB4CCA059FC4}" type="datetimeFigureOut">
               <a:rPr lang="en-US" smtClean="0"/>
-              <a:t>8/18/2026</a:t>
+              <a:t>8/20/2026</a:t>
             </a:fld>
             <a:endParaRPr lang="en-US"/>
           </a:p>
@@ -1489,7 +1489,7 @@
           <a:p>
             <a:fld id="{5BCAD085-E8A6-8845-BD4E-CB4CCA059FC4}" type="datetimeFigureOut">
               <a:rPr lang="en-US" smtClean="0"/>
-              <a:t>8/18/2026</a:t>
+              <a:t>8/20/2026</a:t>
             </a:fld>
             <a:endParaRPr lang="en-US"/>
           </a:p>
@@ -1916,7 +1916,7 @@
           <a:p>
             <a:fld id="{5BCAD085-E8A6-8845-BD4E-CB4CCA059FC4}" type="datetimeFigureOut">
               <a:rPr lang="en-US" smtClean="0"/>
-              <a:t>8/18/2026</a:t>
+              <a:t>8/20/2026</a:t>
             </a:fld>
             <a:endParaRPr lang="en-US"/>
           </a:p>
@@ -2029,7 +2029,7 @@
           <a:p>
             <a:fld id="{5BCAD085-E8A6-8845-BD4E-CB4CCA059FC4}" type="datetimeFigureOut">
               <a:rPr lang="en-US" smtClean="0"/>
-              <a:t>8/18/2026</a:t>
+              <a:t>8/20/2026</a:t>
             </a:fld>
             <a:endParaRPr lang="en-US"/>
           </a:p>
@@ -2348,7 +2348,7 @@
           <a:p>
             <a:fld id="{5BCAD085-E8A6-8845-BD4E-CB4CCA059FC4}" type="datetimeFigureOut">
               <a:rPr lang="en-US" smtClean="0"/>
-              <a:t>8/18/2026</a:t>
+              <a:t>8/20/2026</a:t>
             </a:fld>
             <a:endParaRPr lang="en-US"/>
           </a:p>
@@ -2647,7 +2647,7 @@
           <a:p>
             <a:fld id="{5BCAD085-E8A6-8845-BD4E-CB4CCA059FC4}" type="datetimeFigureOut">
               <a:rPr lang="en-US" smtClean="0"/>
-              <a:t>8/18/2026</a:t>
+              <a:t>8/20/2026</a:t>
             </a:fld>
             <a:endParaRPr lang="en-US"/>
           </a:p>
@@ -2855,7 +2855,7 @@
           <a:p>
             <a:fld id="{5BCAD085-E8A6-8845-BD4E-CB4CCA059FC4}" type="datetimeFigureOut">
               <a:rPr lang="en-US" smtClean="0"/>
-              <a:t>8/18/2026</a:t>
+              <a:t>8/20/2026</a:t>
             </a:fld>
             <a:endParaRPr lang="en-US"/>
           </a:p>
@@ -3133,7 +3133,7 @@
           <a:p>
             <a:fld id="{5BCAD085-E8A6-8845-BD4E-CB4CCA059FC4}" type="datetimeFigureOut">
               <a:rPr lang="en-US" smtClean="0"/>
-              <a:t>8/18/2026</a:t>
+              <a:t>8/20/2026</a:t>
             </a:fld>
             <a:endParaRPr lang="en-US"/>
           </a:p>
@@ -3248,7 +3248,7 @@
             <a:alphaModFix/>
             <a:extLst>
               <a:ext uri="{899FBA48-7B2C-474C-B2AE-7FA3B76AA679}">
-                <a14:useLocalDpi xmlns="" xmlns:a16="http://schemas.microsoft.com/office/drawing/2014/main" xmlns:asvg="http://schemas.microsoft.com/office/drawing/2016/SVG/main" xmlns:p14="http://schemas.microsoft.com/office/powerpoint/2010/main" xmlns:a14="http://schemas.microsoft.com/office/drawing/2010/main" val="0"/>
+                <a14:useLocalDpi xmlns:a14="http://schemas.microsoft.com/office/drawing/2010/main" xmlns:p14="http://schemas.microsoft.com/office/powerpoint/2010/main" xmlns:asvg="http://schemas.microsoft.com/office/drawing/2016/SVG/main" xmlns:a16="http://schemas.microsoft.com/office/drawing/2014/main" xmlns="" val="0"/>
               </a:ext>
             </a:extLst>
           </a:blip>
@@ -5863,7 +5863,14 @@
             </a:pPr>
             <a:r>
               <a:rPr dirty="0"/>
-              <a:t>Event handling in React is how your components respond to user actions like</a:t>
+              <a:t>Event handling in React is how your components respond </a:t>
+            </a:r>
+            <a:br>
+              <a:rPr lang="en-US" dirty="0"/>
+            </a:br>
+            <a:r>
+              <a:rPr dirty="0"/>
+              <a:t>to user actions like</a:t>
             </a:r>
             <a:r>
               <a:rPr lang="en-US" dirty="0"/>
@@ -5871,7 +5878,24 @@
             </a:r>
             <a:r>
               <a:rPr dirty="0"/>
-              <a:t>clicks, typing, submitting forms, hovering, or pressing keys. It is one of the</a:t>
+              <a:t>clicks, typing, submitting forms, hovering,</a:t>
+            </a:r>
+            <a:br>
+              <a:rPr lang="en-US" dirty="0"/>
+            </a:br>
+            <a:r>
+              <a:rPr dirty="0"/>
+              <a:t>or pressing keys. </a:t>
+            </a:r>
+            <a:endParaRPr lang="en-US" dirty="0"/>
+          </a:p>
+          <a:p>
+            <a:pPr>
+              <a:defRPr sz="2200"/>
+            </a:pPr>
+            <a:r>
+              <a:rPr dirty="0"/>
+              <a:t>It is one of the</a:t>
             </a:r>
             <a:r>
               <a:rPr lang="en-US" dirty="0"/>

</xml_diff>